<commit_message>
Change Header Unified Inelligence Hub Presentation
</commit_message>
<xml_diff>
--- a/insurance-ai-hub/docs/Unified_Intelligence_Hub_Presentation.pptx
+++ b/insurance-ai-hub/docs/Unified_Intelligence_Hub_Presentation.pptx
@@ -3118,7 +3118,7 @@
         <p:spPr>
           <a:xfrm>
             <a:off x="914400" y="1371600"/>
-            <a:ext cx="10058400" cy="914400"/>
+            <a:ext cx="10058400" cy="830997"/>
           </a:xfrm>
           <a:prstGeom prst="rect">
             <a:avLst/>
@@ -3139,7 +3139,15 @@
               </a:defRPr>
             </a:pPr>
             <a:r>
-              <a:t>INSURANCE AI HUB</a:t>
+              <a:rPr lang="en-IN"/>
+              <a:t>Unified Intelligence</a:t>
+            </a:r>
+            <a:r>
+              <a:t> </a:t>
+            </a:r>
+            <a:r>
+              <a:rPr dirty="0"/>
+              <a:t>HUB</a:t>
             </a:r>
           </a:p>
         </p:txBody>
@@ -5166,6 +5174,7 @@
               </a:defRPr>
             </a:pPr>
             <a:r>
+              <a:rPr dirty="0"/>
               <a:t>  No single interface for cross-domain questions spanning pricing + churn + recommendations</a:t>
             </a:r>
           </a:p>

</xml_diff>